<commit_message>
fix: proefperiode van 14 naar 30 dagen op website en sales-materials
Ontdekt bij het uitzoeken van de e-mail-dripflow: de app-database
(tenants.trial_ends_at) en het product-backlog-document bevestigen
een proefperiode van 30 dagen, niet 14. Website (Hero.tsx,
pricing.md) en alle 4 sales-materials (PPTX + handout, met en
zonder prijs) hadden nog de oude "14 dagen"-tekst.

Co-Authored-By: Claude Sonnet 4.6 <noreply@anthropic.com>
</commit_message>
<xml_diff>
--- a/sales-materials/EnerCalculatie-klantpresentatie-zonder-prijs.pptx
+++ b/sales-materials/EnerCalculatie-klantpresentatie-zonder-prijs.pptx
@@ -1856,7 +1856,7 @@
       </p:grpSpPr>
       <p:pic>
         <p:nvPicPr>
-          <p:cNvPr id="2" name="Image 0" descr="/private/tmp/pptx-gen2/logo-white.png">    </p:cNvPr>
+          <p:cNvPr id="2" name="Image 0" descr="/private/tmp/pptx-fix/logo-white.png">    </p:cNvPr>
           <p:cNvPicPr>
             <a:picLocks noChangeAspect="1"/>
           </p:cNvPicPr>
@@ -2052,7 +2052,7 @@
       </p:grpSpPr>
       <p:pic>
         <p:nvPicPr>
-          <p:cNvPr id="2" name="Image 0" descr="/private/tmp/pptx-gen2/logo.png">    </p:cNvPr>
+          <p:cNvPr id="2" name="Image 0" descr="/private/tmp/pptx-fix/logo.png">    </p:cNvPr>
           <p:cNvPicPr>
             <a:picLocks noChangeAspect="1"/>
           </p:cNvPicPr>
@@ -2618,7 +2618,7 @@
       </p:grpSpPr>
       <p:pic>
         <p:nvPicPr>
-          <p:cNvPr id="2" name="Image 0" descr="/private/tmp/pptx-gen2/logo-white.png">    </p:cNvPr>
+          <p:cNvPr id="2" name="Image 0" descr="/private/tmp/pptx-fix/logo-white.png">    </p:cNvPr>
           <p:cNvPicPr>
             <a:picLocks noChangeAspect="1"/>
           </p:cNvPicPr>
@@ -2869,7 +2869,7 @@
       </p:grpSpPr>
       <p:pic>
         <p:nvPicPr>
-          <p:cNvPr id="2" name="Image 0" descr="/private/tmp/pptx-gen2/logo.png">    </p:cNvPr>
+          <p:cNvPr id="2" name="Image 0" descr="/private/tmp/pptx-fix/logo.png">    </p:cNvPr>
           <p:cNvPicPr>
             <a:picLocks noChangeAspect="1"/>
           </p:cNvPicPr>
@@ -2994,7 +2994,7 @@
                 <a:ea typeface="Arial" pitchFamily="34" charset="-122"/>
                 <a:cs typeface="Arial" pitchFamily="34" charset="-120"/>
               </a:rPr>
-              <a:t>Start desgewenst een 14 dagen gratis proefperiode — geen verplichtingen</a:t>
+              <a:t>Start desgewenst een 30 dagen gratis proefperiode — geen verplichtingen</a:t>
             </a:r>
             <a:endParaRPr lang="en-US" sz="1800" dirty="0"/>
           </a:p>
@@ -3241,7 +3241,7 @@
       </p:grpSpPr>
       <p:pic>
         <p:nvPicPr>
-          <p:cNvPr id="2" name="Image 0" descr="/private/tmp/pptx-gen2/logo.png">    </p:cNvPr>
+          <p:cNvPr id="2" name="Image 0" descr="/private/tmp/pptx-fix/logo.png">    </p:cNvPr>
           <p:cNvPicPr>
             <a:picLocks noChangeAspect="1"/>
           </p:cNvPicPr>
@@ -3532,7 +3532,7 @@
       </p:grpSpPr>
       <p:pic>
         <p:nvPicPr>
-          <p:cNvPr id="2" name="Image 0" descr="/private/tmp/pptx-gen2/logo-white.png">    </p:cNvPr>
+          <p:cNvPr id="2" name="Image 0" descr="/private/tmp/pptx-fix/logo-white.png">    </p:cNvPr>
           <p:cNvPicPr>
             <a:picLocks noChangeAspect="1"/>
           </p:cNvPicPr>
@@ -3867,7 +3867,7 @@
       </p:grpSpPr>
       <p:pic>
         <p:nvPicPr>
-          <p:cNvPr id="2" name="Image 0" descr="/private/tmp/pptx-gen2/logo.png">    </p:cNvPr>
+          <p:cNvPr id="2" name="Image 0" descr="/private/tmp/pptx-fix/logo.png">    </p:cNvPr>
           <p:cNvPicPr>
             <a:picLocks noChangeAspect="1"/>
           </p:cNvPicPr>
@@ -4511,7 +4511,7 @@
       </p:grpSpPr>
       <p:pic>
         <p:nvPicPr>
-          <p:cNvPr id="2" name="Image 0" descr="/private/tmp/pptx-gen2/logo.png">    </p:cNvPr>
+          <p:cNvPr id="2" name="Image 0" descr="/private/tmp/pptx-fix/logo.png">    </p:cNvPr>
           <p:cNvPicPr>
             <a:picLocks noChangeAspect="1"/>
           </p:cNvPicPr>
@@ -5053,7 +5053,7 @@
       </p:grpSpPr>
       <p:pic>
         <p:nvPicPr>
-          <p:cNvPr id="2" name="Image 0" descr="/private/tmp/pptx-gen2/logo-white.png">    </p:cNvPr>
+          <p:cNvPr id="2" name="Image 0" descr="/private/tmp/pptx-fix/logo-white.png">    </p:cNvPr>
           <p:cNvPicPr>
             <a:picLocks noChangeAspect="1"/>
           </p:cNvPicPr>
@@ -5187,7 +5187,7 @@
       </p:grpSpPr>
       <p:pic>
         <p:nvPicPr>
-          <p:cNvPr id="2" name="Image 0" descr="/private/tmp/pptx-gen2/logo.png">    </p:cNvPr>
+          <p:cNvPr id="2" name="Image 0" descr="/private/tmp/pptx-fix/logo.png">    </p:cNvPr>
           <p:cNvPicPr>
             <a:picLocks noChangeAspect="1"/>
           </p:cNvPicPr>
@@ -5478,7 +5478,7 @@
       </p:grpSpPr>
       <p:pic>
         <p:nvPicPr>
-          <p:cNvPr id="2" name="Image 0" descr="/private/tmp/pptx-gen2/logo.png">    </p:cNvPr>
+          <p:cNvPr id="2" name="Image 0" descr="/private/tmp/pptx-fix/logo.png">    </p:cNvPr>
           <p:cNvPicPr>
             <a:picLocks noChangeAspect="1"/>
           </p:cNvPicPr>
@@ -5966,7 +5966,7 @@
       </p:grpSpPr>
       <p:pic>
         <p:nvPicPr>
-          <p:cNvPr id="2" name="Image 0" descr="/private/tmp/pptx-gen2/logo.png">    </p:cNvPr>
+          <p:cNvPr id="2" name="Image 0" descr="/private/tmp/pptx-fix/logo.png">    </p:cNvPr>
           <p:cNvPicPr>
             <a:picLocks noChangeAspect="1"/>
           </p:cNvPicPr>

</xml_diff>

<commit_message>
fix: hernoem pakket "Solo" naar "Business"
Doorgevoerd op alle plekken: Pricing.tsx (kaart, vergelijkingstabel,
subtitle), PricingCalculator.tsx (weergavenaam; interne key 'solo'
ongewijzigd gelaten), services.ts (rekentool-pagina's), pricing.md,
en alle 4 sales-materials (PPTX + handout, met en zonder prijs).

Co-Authored-By: Claude Sonnet 4.6 <noreply@anthropic.com>
</commit_message>
<xml_diff>
--- a/sales-materials/EnerCalculatie-klantpresentatie-zonder-prijs.pptx
+++ b/sales-materials/EnerCalculatie-klantpresentatie-zonder-prijs.pptx
@@ -1856,7 +1856,7 @@
       </p:grpSpPr>
       <p:pic>
         <p:nvPicPr>
-          <p:cNvPr id="2" name="Image 0" descr="/private/tmp/pptx-fix/logo-white.png">    </p:cNvPr>
+          <p:cNvPr id="2" name="Image 0" descr="/private/tmp/pptx-rename/logo-white.png">    </p:cNvPr>
           <p:cNvPicPr>
             <a:picLocks noChangeAspect="1"/>
           </p:cNvPicPr>
@@ -2052,7 +2052,7 @@
       </p:grpSpPr>
       <p:pic>
         <p:nvPicPr>
-          <p:cNvPr id="2" name="Image 0" descr="/private/tmp/pptx-fix/logo.png">    </p:cNvPr>
+          <p:cNvPr id="2" name="Image 0" descr="/private/tmp/pptx-rename/logo.png">    </p:cNvPr>
           <p:cNvPicPr>
             <a:picLocks noChangeAspect="1"/>
           </p:cNvPicPr>
@@ -2173,7 +2173,7 @@
                 <a:ea typeface="Arial" pitchFamily="34" charset="-122"/>
                 <a:cs typeface="Arial" pitchFamily="34" charset="-120"/>
               </a:rPr>
-              <a:t>Solo</a:t>
+              <a:t>Business</a:t>
             </a:r>
             <a:endParaRPr lang="en-US" sz="2000" dirty="0"/>
           </a:p>
@@ -2356,7 +2356,7 @@
                 <a:ea typeface="Arial" pitchFamily="34" charset="-122"/>
                 <a:cs typeface="Arial" pitchFamily="34" charset="-120"/>
               </a:rPr>
-              <a:t>Alles uit Solo + warmtepomp + technische opname</a:t>
+              <a:t>Alles uit Business + warmtepomp + technische opname</a:t>
             </a:r>
             <a:endParaRPr lang="en-US" sz="1300" dirty="0"/>
           </a:p>
@@ -2618,7 +2618,7 @@
       </p:grpSpPr>
       <p:pic>
         <p:nvPicPr>
-          <p:cNvPr id="2" name="Image 0" descr="/private/tmp/pptx-fix/logo-white.png">    </p:cNvPr>
+          <p:cNvPr id="2" name="Image 0" descr="/private/tmp/pptx-rename/logo-white.png">    </p:cNvPr>
           <p:cNvPicPr>
             <a:picLocks noChangeAspect="1"/>
           </p:cNvPicPr>
@@ -2869,7 +2869,7 @@
       </p:grpSpPr>
       <p:pic>
         <p:nvPicPr>
-          <p:cNvPr id="2" name="Image 0" descr="/private/tmp/pptx-fix/logo.png">    </p:cNvPr>
+          <p:cNvPr id="2" name="Image 0" descr="/private/tmp/pptx-rename/logo.png">    </p:cNvPr>
           <p:cNvPicPr>
             <a:picLocks noChangeAspect="1"/>
           </p:cNvPicPr>
@@ -3241,7 +3241,7 @@
       </p:grpSpPr>
       <p:pic>
         <p:nvPicPr>
-          <p:cNvPr id="2" name="Image 0" descr="/private/tmp/pptx-fix/logo.png">    </p:cNvPr>
+          <p:cNvPr id="2" name="Image 0" descr="/private/tmp/pptx-rename/logo.png">    </p:cNvPr>
           <p:cNvPicPr>
             <a:picLocks noChangeAspect="1"/>
           </p:cNvPicPr>
@@ -3532,7 +3532,7 @@
       </p:grpSpPr>
       <p:pic>
         <p:nvPicPr>
-          <p:cNvPr id="2" name="Image 0" descr="/private/tmp/pptx-fix/logo-white.png">    </p:cNvPr>
+          <p:cNvPr id="2" name="Image 0" descr="/private/tmp/pptx-rename/logo-white.png">    </p:cNvPr>
           <p:cNvPicPr>
             <a:picLocks noChangeAspect="1"/>
           </p:cNvPicPr>
@@ -3867,7 +3867,7 @@
       </p:grpSpPr>
       <p:pic>
         <p:nvPicPr>
-          <p:cNvPr id="2" name="Image 0" descr="/private/tmp/pptx-fix/logo.png">    </p:cNvPr>
+          <p:cNvPr id="2" name="Image 0" descr="/private/tmp/pptx-rename/logo.png">    </p:cNvPr>
           <p:cNvPicPr>
             <a:picLocks noChangeAspect="1"/>
           </p:cNvPicPr>
@@ -4511,7 +4511,7 @@
       </p:grpSpPr>
       <p:pic>
         <p:nvPicPr>
-          <p:cNvPr id="2" name="Image 0" descr="/private/tmp/pptx-fix/logo.png">    </p:cNvPr>
+          <p:cNvPr id="2" name="Image 0" descr="/private/tmp/pptx-rename/logo.png">    </p:cNvPr>
           <p:cNvPicPr>
             <a:picLocks noChangeAspect="1"/>
           </p:cNvPicPr>
@@ -5053,7 +5053,7 @@
       </p:grpSpPr>
       <p:pic>
         <p:nvPicPr>
-          <p:cNvPr id="2" name="Image 0" descr="/private/tmp/pptx-fix/logo-white.png">    </p:cNvPr>
+          <p:cNvPr id="2" name="Image 0" descr="/private/tmp/pptx-rename/logo-white.png">    </p:cNvPr>
           <p:cNvPicPr>
             <a:picLocks noChangeAspect="1"/>
           </p:cNvPicPr>
@@ -5187,7 +5187,7 @@
       </p:grpSpPr>
       <p:pic>
         <p:nvPicPr>
-          <p:cNvPr id="2" name="Image 0" descr="/private/tmp/pptx-fix/logo.png">    </p:cNvPr>
+          <p:cNvPr id="2" name="Image 0" descr="/private/tmp/pptx-rename/logo.png">    </p:cNvPr>
           <p:cNvPicPr>
             <a:picLocks noChangeAspect="1"/>
           </p:cNvPicPr>
@@ -5478,7 +5478,7 @@
       </p:grpSpPr>
       <p:pic>
         <p:nvPicPr>
-          <p:cNvPr id="2" name="Image 0" descr="/private/tmp/pptx-fix/logo.png">    </p:cNvPr>
+          <p:cNvPr id="2" name="Image 0" descr="/private/tmp/pptx-rename/logo.png">    </p:cNvPr>
           <p:cNvPicPr>
             <a:picLocks noChangeAspect="1"/>
           </p:cNvPicPr>
@@ -5966,7 +5966,7 @@
       </p:grpSpPr>
       <p:pic>
         <p:nvPicPr>
-          <p:cNvPr id="2" name="Image 0" descr="/private/tmp/pptx-fix/logo.png">    </p:cNvPr>
+          <p:cNvPr id="2" name="Image 0" descr="/private/tmp/pptx-rename/logo.png">    </p:cNvPr>
           <p:cNvPicPr>
             <a:picLocks noChangeAspect="1"/>
           </p:cNvPicPr>

</xml_diff>